<commit_message>
Personalize project report and presentation
</commit_message>
<xml_diff>
--- a/Documentation/Hotel_Haven_Project_Presentation.pptx
+++ b/Documentation/Hotel_Haven_Project_Presentation.pptx
@@ -3293,8 +3293,8 @@
         </p:nvSpPr>
         <p:spPr>
           <a:xfrm>
-            <a:off x="841248" y="4846320"/>
-            <a:ext cx="5303520" cy="1097280"/>
+            <a:off x="841248" y="4572000"/>
+            <a:ext cx="5303520" cy="1554480"/>
           </a:xfrm>
           <a:prstGeom prst="rect">
             <a:avLst/>
@@ -3302,56 +3302,74 @@
           <a:noFill/>
         </p:spPr>
         <p:txBody>
-          <a:bodyPr wrap="square" lIns="73152" rIns="73152" tIns="73152" bIns="73152">
+          <a:bodyPr wrap="square" lIns="73152" rIns="73152" tIns="27432" bIns="27432">
             <a:spAutoFit/>
           </a:bodyPr>
           <a:lstStyle/>
           <a:p>
-            <a:pPr algn="l">
-              <a:spcAft>
-                <a:spcPts val="600"/>
-              </a:spcAft>
-            </a:pPr>
-            <a:r>
-              <a:rPr sz="1500" b="0">
-                <a:solidFill>
-                  <a:srgbClr val="FFFFFF"/>
-                </a:solidFill>
-                <a:latin typeface="Aptos"/>
-              </a:rPr>
-              <a:t>Presented by: [Your Name]</a:t>
-            </a:r>
-          </a:p>
-          <a:p>
-            <a:pPr algn="l">
-              <a:spcAft>
-                <a:spcPts val="600"/>
-              </a:spcAft>
-            </a:pPr>
-            <a:r>
-              <a:rPr sz="1500" b="0">
-                <a:solidFill>
-                  <a:srgbClr val="FFFFFF"/>
-                </a:solidFill>
-                <a:latin typeface="Aptos"/>
-              </a:rPr>
-              <a:t>Roll No.: [Your Roll Number]</a:t>
-            </a:r>
-          </a:p>
-          <a:p>
-            <a:pPr algn="l">
-              <a:spcAft>
-                <a:spcPts val="600"/>
-              </a:spcAft>
-            </a:pPr>
-            <a:r>
-              <a:rPr sz="1500" b="0">
-                <a:solidFill>
-                  <a:srgbClr val="FFFFFF"/>
-                </a:solidFill>
-                <a:latin typeface="Aptos"/>
-              </a:rPr>
-              <a:t>[College / Institution]</a:t>
+            <a:pPr>
+              <a:spcAft>
+                <a:spcPts val="200"/>
+              </a:spcAft>
+            </a:pPr>
+            <a:r>
+              <a:rPr sz="1200"/>
+              <a:t>Presented by: Swayam Krupesh Nakhwa</a:t>
+            </a:r>
+          </a:p>
+          <a:p>
+            <a:pPr>
+              <a:spcAft>
+                <a:spcPts val="200"/>
+              </a:spcAft>
+            </a:pPr>
+            <a:r>
+              <a:rPr sz="1200"/>
+              <a:t>Roll No.: BT24ECE080</a:t>
+            </a:r>
+          </a:p>
+          <a:p>
+            <a:pPr>
+              <a:spcAft>
+                <a:spcPts val="200"/>
+              </a:spcAft>
+            </a:pPr>
+            <a:r>
+              <a:rPr sz="1200"/>
+              <a:t>Course: Introduction to Object Oriented Programming</a:t>
+            </a:r>
+          </a:p>
+          <a:p>
+            <a:pPr>
+              <a:spcAft>
+                <a:spcPts val="200"/>
+              </a:spcAft>
+            </a:pPr>
+            <a:r>
+              <a:rPr sz="1200"/>
+              <a:t>Semester: 5th Semester</a:t>
+            </a:r>
+          </a:p>
+          <a:p>
+            <a:pPr>
+              <a:spcAft>
+                <a:spcPts val="200"/>
+              </a:spcAft>
+            </a:pPr>
+            <a:r>
+              <a:rPr sz="1200"/>
+              <a:t>Guided by: Aparna Wamanrao Bondade Ma'am</a:t>
+            </a:r>
+          </a:p>
+          <a:p>
+            <a:pPr>
+              <a:spcAft>
+                <a:spcPts val="200"/>
+              </a:spcAft>
+            </a:pPr>
+            <a:r>
+              <a:rPr sz="1200"/>
+              <a:t>Indian Institute of Information Technology Nagpur</a:t>
             </a:r>
           </a:p>
         </p:txBody>

</xml_diff>